<commit_message>
fix(presentation): PowerPoint가 열다 멈추던 원인 제거
템플릿을 원본 발표자료에서 슬라이드만 비워 만들었더니, 그 파일에만 해당하는
패키지 구성이 그대로 따라왔다. 세 가지를 제거한다.

1. <p:embeddedFontLst> + ppt/fonts/*.fntdata (2.9MB)
   원본 76장이 사용한 글자만 담긴 맑은 고딕 서브셋. 새 슬라이드의 한글은
   대부분 그 서브셋 밖이라, PowerPoint가 문서를 커버하지 못하는 임베드 폰트를
   조정하려다 멈춘다. 맑은 고딕은 Windows 기본 폰트라 임베드가 불필요하다.

2. docProps/app.xml
   <Slides>76</Slides>, <Notes>48</Notes>, TitlesOfParts 79개 항목을 선언하는데
   실제 패키지에는 슬라이드가 14장뿐이었다. python-pptx는 이 파트를 재작성하지
   않고 그대로 복사한다.

3. docProps/thumbnail.jpeg + core.xml
   이전 파일의 미리보기와 작성자 정보(revision 122, 3월 생성일).

sanitize_template.py가 위를 제거하고 모든 relationship/content type이
실제 파트를 가리키는지 검증한다. build_deck.py는 저장 직후 같은 검사에
더해 임베드 폰트 재유입과 app.xml 슬라이드 수 불일치를 assert한다.

3.53MB -> 0.66MB. 렌더링 결과는 동일하다.

Co-Authored-By: Claude Opus 5 <noreply@anthropic.com>
Claude-Session: https://claude.ai/code/session_01N6CDnKBozb5KPELnSibfaE
</commit_message>
<xml_diff>
--- a/presentation/POD-Bench_성과발표.pptx
+++ b/presentation/POD-Bench_성과발표.pptx
@@ -8,30 +8,23 @@
     <p:notesMasterId r:id="rId78"/>
   </p:notesMasterIdLst>
   <p:sldIdLst>
-    <p:sldId id="256" r:id="rId9"/>
-    <p:sldId id="257" r:id="rId10"/>
-    <p:sldId id="258" r:id="rId11"/>
-    <p:sldId id="259" r:id="rId12"/>
-    <p:sldId id="260" r:id="rId13"/>
-    <p:sldId id="261" r:id="rId14"/>
-    <p:sldId id="262" r:id="rId15"/>
-    <p:sldId id="263" r:id="rId16"/>
-    <p:sldId id="264" r:id="rId17"/>
-    <p:sldId id="265" r:id="rId18"/>
-    <p:sldId id="266" r:id="rId19"/>
-    <p:sldId id="267" r:id="rId20"/>
-    <p:sldId id="268" r:id="rId21"/>
-    <p:sldId id="269" r:id="rId22"/>
+    <p:sldId id="256" r:id="rId7"/>
+    <p:sldId id="257" r:id="rId8"/>
+    <p:sldId id="258" r:id="rId9"/>
+    <p:sldId id="259" r:id="rId10"/>
+    <p:sldId id="260" r:id="rId11"/>
+    <p:sldId id="261" r:id="rId12"/>
+    <p:sldId id="262" r:id="rId13"/>
+    <p:sldId id="263" r:id="rId14"/>
+    <p:sldId id="264" r:id="rId15"/>
+    <p:sldId id="265" r:id="rId16"/>
+    <p:sldId id="266" r:id="rId17"/>
+    <p:sldId id="267" r:id="rId18"/>
+    <p:sldId id="268" r:id="rId19"/>
+    <p:sldId id="269" r:id="rId20"/>
   </p:sldIdLst>
   <p:sldSz cx="9906000" cy="6858000" type="A4"/>
   <p:notesSz cx="6858000" cy="9144000"/>
-  <p:embeddedFontLst>
-    <p:embeddedFont>
-      <p:font typeface="맑은 고딕" panose="020B0503020000020004" pitchFamily="50" charset="-127"/>
-      <p:regular r:id="rId79"/>
-      <p:bold r:id="rId80"/>
-    </p:embeddedFont>
-  </p:embeddedFontLst>
   <p:defaultTextStyle>
     <a:defPPr>
       <a:defRPr lang="ko-KR"/>

</xml_diff>